<commit_message>
Adaugat diacritice. Sper sa le fi pus pe toate
</commit_message>
<xml_diff>
--- a/PresentareSPG.pptx
+++ b/PresentareSPG.pptx
@@ -110,6 +110,11 @@
       </a:defRPr>
     </a:lvl9pPr>
   </p:defaultTextStyle>
+  <p:extLst>
+    <p:ext uri="{EFAFB233-063F-42B5-8137-9DF3F51BA10A}">
+      <p15:sldGuideLst xmlns:p15="http://schemas.microsoft.com/office/powerpoint/2012/main"/>
+    </p:ext>
+  </p:extLst>
 </p:presentation>
 </file>
 
@@ -262,7 +267,7 @@
           <a:p>
             <a:fld id="{D4AE94A9-E9EE-45B6-96B2-E6EA99554933}" type="datetimeFigureOut">
               <a:rPr lang="ro-RO" smtClean="0"/>
-              <a:t>10.05.2026</a:t>
+              <a:t>18.05.2026</a:t>
             </a:fld>
             <a:endParaRPr lang="ro-RO"/>
           </a:p>
@@ -462,7 +467,7 @@
           <a:p>
             <a:fld id="{D4AE94A9-E9EE-45B6-96B2-E6EA99554933}" type="datetimeFigureOut">
               <a:rPr lang="ro-RO" smtClean="0"/>
-              <a:t>10.05.2026</a:t>
+              <a:t>18.05.2026</a:t>
             </a:fld>
             <a:endParaRPr lang="ro-RO"/>
           </a:p>
@@ -672,7 +677,7 @@
           <a:p>
             <a:fld id="{D4AE94A9-E9EE-45B6-96B2-E6EA99554933}" type="datetimeFigureOut">
               <a:rPr lang="ro-RO" smtClean="0"/>
-              <a:t>10.05.2026</a:t>
+              <a:t>18.05.2026</a:t>
             </a:fld>
             <a:endParaRPr lang="ro-RO"/>
           </a:p>
@@ -872,7 +877,7 @@
           <a:p>
             <a:fld id="{D4AE94A9-E9EE-45B6-96B2-E6EA99554933}" type="datetimeFigureOut">
               <a:rPr lang="ro-RO" smtClean="0"/>
-              <a:t>10.05.2026</a:t>
+              <a:t>18.05.2026</a:t>
             </a:fld>
             <a:endParaRPr lang="ro-RO"/>
           </a:p>
@@ -1148,7 +1153,7 @@
           <a:p>
             <a:fld id="{D4AE94A9-E9EE-45B6-96B2-E6EA99554933}" type="datetimeFigureOut">
               <a:rPr lang="ro-RO" smtClean="0"/>
-              <a:t>10.05.2026</a:t>
+              <a:t>18.05.2026</a:t>
             </a:fld>
             <a:endParaRPr lang="ro-RO"/>
           </a:p>
@@ -1416,7 +1421,7 @@
           <a:p>
             <a:fld id="{D4AE94A9-E9EE-45B6-96B2-E6EA99554933}" type="datetimeFigureOut">
               <a:rPr lang="ro-RO" smtClean="0"/>
-              <a:t>10.05.2026</a:t>
+              <a:t>18.05.2026</a:t>
             </a:fld>
             <a:endParaRPr lang="ro-RO"/>
           </a:p>
@@ -1831,7 +1836,7 @@
           <a:p>
             <a:fld id="{D4AE94A9-E9EE-45B6-96B2-E6EA99554933}" type="datetimeFigureOut">
               <a:rPr lang="ro-RO" smtClean="0"/>
-              <a:t>10.05.2026</a:t>
+              <a:t>18.05.2026</a:t>
             </a:fld>
             <a:endParaRPr lang="ro-RO"/>
           </a:p>
@@ -1973,7 +1978,7 @@
           <a:p>
             <a:fld id="{D4AE94A9-E9EE-45B6-96B2-E6EA99554933}" type="datetimeFigureOut">
               <a:rPr lang="ro-RO" smtClean="0"/>
-              <a:t>10.05.2026</a:t>
+              <a:t>18.05.2026</a:t>
             </a:fld>
             <a:endParaRPr lang="ro-RO"/>
           </a:p>
@@ -2086,7 +2091,7 @@
           <a:p>
             <a:fld id="{D4AE94A9-E9EE-45B6-96B2-E6EA99554933}" type="datetimeFigureOut">
               <a:rPr lang="ro-RO" smtClean="0"/>
-              <a:t>10.05.2026</a:t>
+              <a:t>18.05.2026</a:t>
             </a:fld>
             <a:endParaRPr lang="ro-RO"/>
           </a:p>
@@ -2399,7 +2404,7 @@
           <a:p>
             <a:fld id="{D4AE94A9-E9EE-45B6-96B2-E6EA99554933}" type="datetimeFigureOut">
               <a:rPr lang="ro-RO" smtClean="0"/>
-              <a:t>10.05.2026</a:t>
+              <a:t>18.05.2026</a:t>
             </a:fld>
             <a:endParaRPr lang="ro-RO"/>
           </a:p>
@@ -2688,7 +2693,7 @@
           <a:p>
             <a:fld id="{D4AE94A9-E9EE-45B6-96B2-E6EA99554933}" type="datetimeFigureOut">
               <a:rPr lang="ro-RO" smtClean="0"/>
-              <a:t>10.05.2026</a:t>
+              <a:t>18.05.2026</a:t>
             </a:fld>
             <a:endParaRPr lang="ro-RO"/>
           </a:p>
@@ -2931,7 +2936,7 @@
           <a:p>
             <a:fld id="{D4AE94A9-E9EE-45B6-96B2-E6EA99554933}" type="datetimeFigureOut">
               <a:rPr lang="ro-RO" smtClean="0"/>
-              <a:t>10.05.2026</a:t>
+              <a:t>18.05.2026</a:t>
             </a:fld>
             <a:endParaRPr lang="ro-RO"/>
           </a:p>
@@ -3395,28 +3400,42 @@
                 <a:latin typeface="Times New Roman" panose="02020603050405020304" pitchFamily="18" charset="0"/>
                 <a:cs typeface="Times New Roman" panose="02020603050405020304" pitchFamily="18" charset="0"/>
               </a:rPr>
-              <a:t> </a:t>
+              <a:t> ma</a:t>
+            </a:r>
+            <a:r>
+              <a:rPr lang="ro-RO" b="1" dirty="0">
+                <a:latin typeface="Times New Roman" panose="02020603050405020304" pitchFamily="18" charset="0"/>
+                <a:cs typeface="Times New Roman" panose="02020603050405020304" pitchFamily="18" charset="0"/>
+              </a:rPr>
+              <a:t>ș</a:t>
             </a:r>
             <a:r>
               <a:rPr lang="en-US" b="1" dirty="0" err="1">
                 <a:latin typeface="Times New Roman" panose="02020603050405020304" pitchFamily="18" charset="0"/>
                 <a:cs typeface="Times New Roman" panose="02020603050405020304" pitchFamily="18" charset="0"/>
               </a:rPr>
-              <a:t>masinii</a:t>
+              <a:t>ini</a:t>
             </a:r>
             <a:r>
               <a:rPr lang="en-US" b="1" dirty="0">
                 <a:latin typeface="Times New Roman" panose="02020603050405020304" pitchFamily="18" charset="0"/>
                 <a:cs typeface="Times New Roman" panose="02020603050405020304" pitchFamily="18" charset="0"/>
               </a:rPr>
-              <a:t> de </a:t>
+              <a:t> de poli</a:t>
+            </a:r>
+            <a:r>
+              <a:rPr lang="ro-RO" b="1" dirty="0">
+                <a:latin typeface="Times New Roman" panose="02020603050405020304" pitchFamily="18" charset="0"/>
+                <a:cs typeface="Times New Roman" panose="02020603050405020304" pitchFamily="18" charset="0"/>
+              </a:rPr>
+              <a:t>ț</a:t>
             </a:r>
             <a:r>
               <a:rPr lang="en-US" b="1" dirty="0" err="1">
                 <a:latin typeface="Times New Roman" panose="02020603050405020304" pitchFamily="18" charset="0"/>
                 <a:cs typeface="Times New Roman" panose="02020603050405020304" pitchFamily="18" charset="0"/>
               </a:rPr>
-              <a:t>politie</a:t>
+              <a:t>ie</a:t>
             </a:r>
             <a:endParaRPr lang="ro-RO" dirty="0">
               <a:latin typeface="Times New Roman" panose="02020603050405020304" pitchFamily="18" charset="0"/>
@@ -3581,14 +3600,49 @@
                 <a:latin typeface="Times New Roman" panose="02020603050405020304" pitchFamily="18" charset="0"/>
                 <a:cs typeface="Times New Roman" panose="02020603050405020304" pitchFamily="18" charset="0"/>
               </a:rPr>
-              <a:t>Masina de </a:t>
-            </a:r>
-            <a:r>
-              <a:rPr lang="en-US" dirty="0" err="1">
-                <a:latin typeface="Times New Roman" panose="02020603050405020304" pitchFamily="18" charset="0"/>
-                <a:cs typeface="Times New Roman" panose="02020603050405020304" pitchFamily="18" charset="0"/>
-              </a:rPr>
-              <a:t>politie</a:t>
+              <a:t>Ma</a:t>
+            </a:r>
+            <a:r>
+              <a:rPr lang="ro-RO" dirty="0">
+                <a:latin typeface="Times New Roman" panose="02020603050405020304" pitchFamily="18" charset="0"/>
+                <a:cs typeface="Times New Roman" panose="02020603050405020304" pitchFamily="18" charset="0"/>
+              </a:rPr>
+              <a:t>ș</a:t>
+            </a:r>
+            <a:r>
+              <a:rPr lang="en-US" dirty="0">
+                <a:latin typeface="Times New Roman" panose="02020603050405020304" pitchFamily="18" charset="0"/>
+                <a:cs typeface="Times New Roman" panose="02020603050405020304" pitchFamily="18" charset="0"/>
+              </a:rPr>
+              <a:t>in</a:t>
+            </a:r>
+            <a:r>
+              <a:rPr lang="ro-RO" dirty="0">
+                <a:latin typeface="Times New Roman" panose="02020603050405020304" pitchFamily="18" charset="0"/>
+                <a:cs typeface="Times New Roman" panose="02020603050405020304" pitchFamily="18" charset="0"/>
+              </a:rPr>
+              <a:t>ă</a:t>
+            </a:r>
+            <a:r>
+              <a:rPr lang="en-US" dirty="0">
+                <a:latin typeface="Times New Roman" panose="02020603050405020304" pitchFamily="18" charset="0"/>
+                <a:cs typeface="Times New Roman" panose="02020603050405020304" pitchFamily="18" charset="0"/>
+              </a:rPr>
+              <a:t> de poli</a:t>
+            </a:r>
+            <a:r>
+              <a:rPr lang="ro-RO" dirty="0">
+                <a:latin typeface="Times New Roman" panose="02020603050405020304" pitchFamily="18" charset="0"/>
+                <a:cs typeface="Times New Roman" panose="02020603050405020304" pitchFamily="18" charset="0"/>
+              </a:rPr>
+              <a:t>ț</a:t>
+            </a:r>
+            <a:r>
+              <a:rPr lang="en-US" dirty="0" err="1">
+                <a:latin typeface="Times New Roman" panose="02020603050405020304" pitchFamily="18" charset="0"/>
+                <a:cs typeface="Times New Roman" panose="02020603050405020304" pitchFamily="18" charset="0"/>
+              </a:rPr>
+              <a:t>ie</a:t>
             </a:r>
             <a:r>
               <a:rPr lang="en-US" dirty="0">
@@ -3598,11 +3652,18 @@
               <a:t>, </a:t>
             </a:r>
             <a:r>
-              <a:rPr lang="en-US" dirty="0" err="1">
-                <a:latin typeface="Times New Roman" panose="02020603050405020304" pitchFamily="18" charset="0"/>
-                <a:cs typeface="Times New Roman" panose="02020603050405020304" pitchFamily="18" charset="0"/>
-              </a:rPr>
-              <a:t>intr</a:t>
+              <a:rPr lang="ro-RO" dirty="0">
+                <a:latin typeface="Times New Roman" panose="02020603050405020304" pitchFamily="18" charset="0"/>
+                <a:cs typeface="Times New Roman" panose="02020603050405020304" pitchFamily="18" charset="0"/>
+              </a:rPr>
+              <a:t>î</a:t>
+            </a:r>
+            <a:r>
+              <a:rPr lang="en-US" dirty="0" err="1">
+                <a:latin typeface="Times New Roman" panose="02020603050405020304" pitchFamily="18" charset="0"/>
+                <a:cs typeface="Times New Roman" panose="02020603050405020304" pitchFamily="18" charset="0"/>
+              </a:rPr>
+              <a:t>ntr</a:t>
             </a:r>
             <a:r>
               <a:rPr lang="en-US" dirty="0">
@@ -3616,7 +3677,14 @@
                 <a:latin typeface="Times New Roman" panose="02020603050405020304" pitchFamily="18" charset="0"/>
                 <a:cs typeface="Times New Roman" panose="02020603050405020304" pitchFamily="18" charset="0"/>
               </a:rPr>
-              <a:t>oras</a:t>
+              <a:t>ora</a:t>
+            </a:r>
+            <a:r>
+              <a:rPr lang="ro-RO" dirty="0">
+                <a:latin typeface="Times New Roman" panose="02020603050405020304" pitchFamily="18" charset="0"/>
+                <a:cs typeface="Times New Roman" panose="02020603050405020304" pitchFamily="18" charset="0"/>
+              </a:rPr>
+              <a:t>ș</a:t>
             </a:r>
             <a:r>
               <a:rPr lang="en-US" dirty="0">
@@ -3710,11 +3778,18 @@
               <a:t> </a:t>
             </a:r>
             <a:r>
-              <a:rPr lang="en-US" dirty="0" err="1">
-                <a:latin typeface="Times New Roman" panose="02020603050405020304" pitchFamily="18" charset="0"/>
-                <a:cs typeface="Times New Roman" panose="02020603050405020304" pitchFamily="18" charset="0"/>
-              </a:rPr>
-              <a:t>si</a:t>
+              <a:rPr lang="ro-RO" dirty="0">
+                <a:latin typeface="Times New Roman" panose="02020603050405020304" pitchFamily="18" charset="0"/>
+                <a:cs typeface="Times New Roman" panose="02020603050405020304" pitchFamily="18" charset="0"/>
+              </a:rPr>
+              <a:t>ș</a:t>
+            </a:r>
+            <a:r>
+              <a:rPr lang="en-US" dirty="0" err="1">
+                <a:latin typeface="Times New Roman" panose="02020603050405020304" pitchFamily="18" charset="0"/>
+                <a:cs typeface="Times New Roman" panose="02020603050405020304" pitchFamily="18" charset="0"/>
+              </a:rPr>
+              <a:t>i</a:t>
             </a:r>
             <a:r>
               <a:rPr lang="en-US" dirty="0">
@@ -3752,11 +3827,18 @@
               <a:t> de tip “shadow map” </a:t>
             </a:r>
             <a:r>
-              <a:rPr lang="en-US" dirty="0" err="1">
-                <a:latin typeface="Times New Roman" panose="02020603050405020304" pitchFamily="18" charset="0"/>
-                <a:cs typeface="Times New Roman" panose="02020603050405020304" pitchFamily="18" charset="0"/>
-              </a:rPr>
-              <a:t>si</a:t>
+              <a:rPr lang="ro-RO" dirty="0">
+                <a:latin typeface="Times New Roman" panose="02020603050405020304" pitchFamily="18" charset="0"/>
+                <a:cs typeface="Times New Roman" panose="02020603050405020304" pitchFamily="18" charset="0"/>
+              </a:rPr>
+              <a:t>ș</a:t>
+            </a:r>
+            <a:r>
+              <a:rPr lang="en-US" dirty="0" err="1">
+                <a:latin typeface="Times New Roman" panose="02020603050405020304" pitchFamily="18" charset="0"/>
+                <a:cs typeface="Times New Roman" panose="02020603050405020304" pitchFamily="18" charset="0"/>
+              </a:rPr>
+              <a:t>i</a:t>
             </a:r>
             <a:r>
               <a:rPr lang="en-US" dirty="0">
@@ -3765,266 +3847,361 @@
               </a:rPr>
               <a:t> “shadow cube”</a:t>
             </a:r>
-          </a:p>
-          <a:p>
-            <a:r>
-              <a:rPr lang="en-US" dirty="0" err="1">
-                <a:latin typeface="Times New Roman" panose="02020603050405020304" pitchFamily="18" charset="0"/>
-                <a:cs typeface="Times New Roman" panose="02020603050405020304" pitchFamily="18" charset="0"/>
-              </a:rPr>
-              <a:t>Inspiratie</a:t>
-            </a:r>
-            <a:r>
-              <a:rPr lang="en-US" dirty="0">
-                <a:latin typeface="Times New Roman" panose="02020603050405020304" pitchFamily="18" charset="0"/>
-                <a:cs typeface="Times New Roman" panose="02020603050405020304" pitchFamily="18" charset="0"/>
-              </a:rPr>
-              <a:t>: Need For Speed Most Wanted (2005), </a:t>
-            </a:r>
-            <a:r>
-              <a:rPr lang="en-US" dirty="0" err="1">
-                <a:latin typeface="Times New Roman" panose="02020603050405020304" pitchFamily="18" charset="0"/>
-                <a:cs typeface="Times New Roman" panose="02020603050405020304" pitchFamily="18" charset="0"/>
-              </a:rPr>
-              <a:t>jocuri</a:t>
-            </a:r>
-            <a:r>
-              <a:rPr lang="en-US" dirty="0">
-                <a:latin typeface="Times New Roman" panose="02020603050405020304" pitchFamily="18" charset="0"/>
-                <a:cs typeface="Times New Roman" panose="02020603050405020304" pitchFamily="18" charset="0"/>
-              </a:rPr>
-              <a:t> in </a:t>
-            </a:r>
-            <a:r>
-              <a:rPr lang="en-US" dirty="0" err="1">
-                <a:latin typeface="Times New Roman" panose="02020603050405020304" pitchFamily="18" charset="0"/>
-                <a:cs typeface="Times New Roman" panose="02020603050405020304" pitchFamily="18" charset="0"/>
-              </a:rPr>
-              <a:t>stil</a:t>
-            </a:r>
-            <a:r>
-              <a:rPr lang="en-US" dirty="0">
-                <a:latin typeface="Times New Roman" panose="02020603050405020304" pitchFamily="18" charset="0"/>
-                <a:cs typeface="Times New Roman" panose="02020603050405020304" pitchFamily="18" charset="0"/>
-              </a:rPr>
-              <a:t> “arcade” (</a:t>
-            </a:r>
-            <a:r>
-              <a:rPr lang="en-US" dirty="0" err="1">
-                <a:latin typeface="Times New Roman" panose="02020603050405020304" pitchFamily="18" charset="0"/>
-                <a:cs typeface="Times New Roman" panose="02020603050405020304" pitchFamily="18" charset="0"/>
-              </a:rPr>
-              <a:t>unele</a:t>
-            </a:r>
-            <a:r>
-              <a:rPr lang="en-US" dirty="0">
-                <a:latin typeface="Times New Roman" panose="02020603050405020304" pitchFamily="18" charset="0"/>
-                <a:cs typeface="Times New Roman" panose="02020603050405020304" pitchFamily="18" charset="0"/>
-              </a:rPr>
-              <a:t> aspect sunt </a:t>
-            </a:r>
-            <a:r>
-              <a:rPr lang="en-US" dirty="0" err="1">
-                <a:latin typeface="Times New Roman" panose="02020603050405020304" pitchFamily="18" charset="0"/>
-                <a:cs typeface="Times New Roman" panose="02020603050405020304" pitchFamily="18" charset="0"/>
-              </a:rPr>
-              <a:t>exagerate</a:t>
-            </a:r>
-            <a:r>
-              <a:rPr lang="en-US" dirty="0">
-                <a:latin typeface="Times New Roman" panose="02020603050405020304" pitchFamily="18" charset="0"/>
-                <a:cs typeface="Times New Roman" panose="02020603050405020304" pitchFamily="18" charset="0"/>
-              </a:rPr>
-              <a:t>)</a:t>
-            </a:r>
-          </a:p>
-          <a:p>
-            <a:r>
-              <a:rPr lang="en-US" dirty="0" err="1">
-                <a:latin typeface="Times New Roman" panose="02020603050405020304" pitchFamily="18" charset="0"/>
-                <a:cs typeface="Times New Roman" panose="02020603050405020304" pitchFamily="18" charset="0"/>
-              </a:rPr>
-              <a:t>Obiective</a:t>
-            </a:r>
-            <a:r>
-              <a:rPr lang="en-US" dirty="0">
-                <a:latin typeface="Times New Roman" panose="02020603050405020304" pitchFamily="18" charset="0"/>
-                <a:cs typeface="Times New Roman" panose="02020603050405020304" pitchFamily="18" charset="0"/>
-              </a:rPr>
-              <a:t>: </a:t>
-            </a:r>
-            <a:r>
-              <a:rPr lang="en-US" dirty="0" err="1">
-                <a:latin typeface="Times New Roman" panose="02020603050405020304" pitchFamily="18" charset="0"/>
-                <a:cs typeface="Times New Roman" panose="02020603050405020304" pitchFamily="18" charset="0"/>
-              </a:rPr>
-              <a:t>Crearea</a:t>
-            </a:r>
-            <a:r>
-              <a:rPr lang="en-US" dirty="0">
-                <a:latin typeface="Times New Roman" panose="02020603050405020304" pitchFamily="18" charset="0"/>
-                <a:cs typeface="Times New Roman" panose="02020603050405020304" pitchFamily="18" charset="0"/>
-              </a:rPr>
-              <a:t> </a:t>
-            </a:r>
-            <a:r>
-              <a:rPr lang="en-US" dirty="0" err="1">
-                <a:latin typeface="Times New Roman" panose="02020603050405020304" pitchFamily="18" charset="0"/>
-                <a:cs typeface="Times New Roman" panose="02020603050405020304" pitchFamily="18" charset="0"/>
-              </a:rPr>
-              <a:t>masinii</a:t>
-            </a:r>
-            <a:r>
-              <a:rPr lang="en-US" dirty="0">
-                <a:latin typeface="Times New Roman" panose="02020603050405020304" pitchFamily="18" charset="0"/>
-                <a:cs typeface="Times New Roman" panose="02020603050405020304" pitchFamily="18" charset="0"/>
-              </a:rPr>
-              <a:t> de </a:t>
-            </a:r>
-            <a:r>
-              <a:rPr lang="en-US" dirty="0" err="1">
-                <a:latin typeface="Times New Roman" panose="02020603050405020304" pitchFamily="18" charset="0"/>
-                <a:cs typeface="Times New Roman" panose="02020603050405020304" pitchFamily="18" charset="0"/>
-              </a:rPr>
-              <a:t>politie</a:t>
-            </a:r>
-            <a:r>
-              <a:rPr lang="en-US" dirty="0">
-                <a:latin typeface="Times New Roman" panose="02020603050405020304" pitchFamily="18" charset="0"/>
-                <a:cs typeface="Times New Roman" panose="02020603050405020304" pitchFamily="18" charset="0"/>
-              </a:rPr>
-              <a:t>, </a:t>
-            </a:r>
-            <a:r>
-              <a:rPr lang="en-US" dirty="0" err="1">
-                <a:latin typeface="Times New Roman" panose="02020603050405020304" pitchFamily="18" charset="0"/>
-                <a:cs typeface="Times New Roman" panose="02020603050405020304" pitchFamily="18" charset="0"/>
-              </a:rPr>
-              <a:t>orasului</a:t>
-            </a:r>
-            <a:r>
-              <a:rPr lang="en-US" dirty="0">
-                <a:latin typeface="Times New Roman" panose="02020603050405020304" pitchFamily="18" charset="0"/>
-                <a:cs typeface="Times New Roman" panose="02020603050405020304" pitchFamily="18" charset="0"/>
-              </a:rPr>
-              <a:t>, “</a:t>
-            </a:r>
-            <a:r>
-              <a:rPr lang="en-US" dirty="0" err="1">
-                <a:latin typeface="Times New Roman" panose="02020603050405020304" pitchFamily="18" charset="0"/>
-                <a:cs typeface="Times New Roman" panose="02020603050405020304" pitchFamily="18" charset="0"/>
-              </a:rPr>
-              <a:t>masinii</a:t>
-            </a:r>
-            <a:r>
-              <a:rPr lang="en-US" dirty="0">
-                <a:latin typeface="Times New Roman" panose="02020603050405020304" pitchFamily="18" charset="0"/>
-                <a:cs typeface="Times New Roman" panose="02020603050405020304" pitchFamily="18" charset="0"/>
-              </a:rPr>
-              <a:t> </a:t>
-            </a:r>
-            <a:r>
-              <a:rPr lang="en-US" dirty="0" err="1">
-                <a:latin typeface="Times New Roman" panose="02020603050405020304" pitchFamily="18" charset="0"/>
-                <a:cs typeface="Times New Roman" panose="02020603050405020304" pitchFamily="18" charset="0"/>
-              </a:rPr>
-              <a:t>criminale</a:t>
-            </a:r>
-            <a:r>
-              <a:rPr lang="en-US" dirty="0">
-                <a:latin typeface="Times New Roman" panose="02020603050405020304" pitchFamily="18" charset="0"/>
-                <a:cs typeface="Times New Roman" panose="02020603050405020304" pitchFamily="18" charset="0"/>
-              </a:rPr>
-              <a:t>”, </a:t>
-            </a:r>
-            <a:r>
-              <a:rPr lang="en-US" dirty="0" err="1">
-                <a:latin typeface="Times New Roman" panose="02020603050405020304" pitchFamily="18" charset="0"/>
-                <a:cs typeface="Times New Roman" panose="02020603050405020304" pitchFamily="18" charset="0"/>
-              </a:rPr>
-              <a:t>modelului</a:t>
-            </a:r>
-            <a:r>
-              <a:rPr lang="en-US" dirty="0">
-                <a:latin typeface="Times New Roman" panose="02020603050405020304" pitchFamily="18" charset="0"/>
-                <a:cs typeface="Times New Roman" panose="02020603050405020304" pitchFamily="18" charset="0"/>
-              </a:rPr>
-              <a:t> de </a:t>
-            </a:r>
-            <a:r>
-              <a:rPr lang="en-US" dirty="0" err="1">
-                <a:latin typeface="Times New Roman" panose="02020603050405020304" pitchFamily="18" charset="0"/>
-                <a:cs typeface="Times New Roman" panose="02020603050405020304" pitchFamily="18" charset="0"/>
-              </a:rPr>
-              <a:t>iluminare</a:t>
-            </a:r>
-            <a:r>
-              <a:rPr lang="en-US" dirty="0">
-                <a:latin typeface="Times New Roman" panose="02020603050405020304" pitchFamily="18" charset="0"/>
-                <a:cs typeface="Times New Roman" panose="02020603050405020304" pitchFamily="18" charset="0"/>
-              </a:rPr>
-              <a:t> / </a:t>
-            </a:r>
-            <a:r>
-              <a:rPr lang="en-US" dirty="0" err="1">
-                <a:latin typeface="Times New Roman" panose="02020603050405020304" pitchFamily="18" charset="0"/>
-                <a:cs typeface="Times New Roman" panose="02020603050405020304" pitchFamily="18" charset="0"/>
-              </a:rPr>
-              <a:t>umbrire</a:t>
-            </a:r>
-            <a:r>
-              <a:rPr lang="en-US" dirty="0">
-                <a:latin typeface="Times New Roman" panose="02020603050405020304" pitchFamily="18" charset="0"/>
-                <a:cs typeface="Times New Roman" panose="02020603050405020304" pitchFamily="18" charset="0"/>
-              </a:rPr>
-              <a:t> </a:t>
-            </a:r>
-            <a:r>
-              <a:rPr lang="en-US" dirty="0" err="1">
-                <a:latin typeface="Times New Roman" panose="02020603050405020304" pitchFamily="18" charset="0"/>
-                <a:cs typeface="Times New Roman" panose="02020603050405020304" pitchFamily="18" charset="0"/>
-              </a:rPr>
-              <a:t>phong</a:t>
-            </a:r>
-            <a:r>
-              <a:rPr lang="en-US" dirty="0">
-                <a:latin typeface="Times New Roman" panose="02020603050405020304" pitchFamily="18" charset="0"/>
-                <a:cs typeface="Times New Roman" panose="02020603050405020304" pitchFamily="18" charset="0"/>
-              </a:rPr>
-              <a:t>, </a:t>
-            </a:r>
-            <a:r>
-              <a:rPr lang="en-US" dirty="0" err="1">
-                <a:latin typeface="Times New Roman" panose="02020603050405020304" pitchFamily="18" charset="0"/>
-                <a:cs typeface="Times New Roman" panose="02020603050405020304" pitchFamily="18" charset="0"/>
-              </a:rPr>
-              <a:t>tehnicilor</a:t>
-            </a:r>
-            <a:r>
-              <a:rPr lang="en-US" dirty="0">
-                <a:latin typeface="Times New Roman" panose="02020603050405020304" pitchFamily="18" charset="0"/>
-                <a:cs typeface="Times New Roman" panose="02020603050405020304" pitchFamily="18" charset="0"/>
-              </a:rPr>
-              <a:t> “shadow map” </a:t>
-            </a:r>
-            <a:r>
-              <a:rPr lang="en-US" dirty="0" err="1">
-                <a:latin typeface="Times New Roman" panose="02020603050405020304" pitchFamily="18" charset="0"/>
-                <a:cs typeface="Times New Roman" panose="02020603050405020304" pitchFamily="18" charset="0"/>
-              </a:rPr>
-              <a:t>si</a:t>
-            </a:r>
-            <a:r>
-              <a:rPr lang="en-US" dirty="0">
-                <a:latin typeface="Times New Roman" panose="02020603050405020304" pitchFamily="18" charset="0"/>
-                <a:cs typeface="Times New Roman" panose="02020603050405020304" pitchFamily="18" charset="0"/>
-              </a:rPr>
-              <a:t> “shadow cube”</a:t>
-            </a:r>
-            <a:endParaRPr lang="ro-RO" dirty="0">
+            <a:r>
+              <a:rPr lang="ro-RO" dirty="0">
+                <a:latin typeface="Times New Roman" panose="02020603050405020304" pitchFamily="18" charset="0"/>
+                <a:cs typeface="Times New Roman" panose="02020603050405020304" pitchFamily="18" charset="0"/>
+              </a:rPr>
+              <a:t>.</a:t>
+            </a:r>
+            <a:endParaRPr lang="en-US" dirty="0">
               <a:latin typeface="Times New Roman" panose="02020603050405020304" pitchFamily="18" charset="0"/>
               <a:cs typeface="Times New Roman" panose="02020603050405020304" pitchFamily="18" charset="0"/>
             </a:endParaRPr>
+          </a:p>
+          <a:p>
+            <a:r>
+              <a:rPr lang="en-US" dirty="0">
+                <a:latin typeface="Times New Roman" panose="02020603050405020304" pitchFamily="18" charset="0"/>
+                <a:cs typeface="Times New Roman" panose="02020603050405020304" pitchFamily="18" charset="0"/>
+              </a:rPr>
+              <a:t>Inspira</a:t>
+            </a:r>
+            <a:r>
+              <a:rPr lang="ro-RO" dirty="0">
+                <a:latin typeface="Times New Roman" panose="02020603050405020304" pitchFamily="18" charset="0"/>
+                <a:cs typeface="Times New Roman" panose="02020603050405020304" pitchFamily="18" charset="0"/>
+              </a:rPr>
+              <a:t>ț</a:t>
+            </a:r>
+            <a:r>
+              <a:rPr lang="en-US" dirty="0" err="1">
+                <a:latin typeface="Times New Roman" panose="02020603050405020304" pitchFamily="18" charset="0"/>
+                <a:cs typeface="Times New Roman" panose="02020603050405020304" pitchFamily="18" charset="0"/>
+              </a:rPr>
+              <a:t>ie</a:t>
+            </a:r>
+            <a:r>
+              <a:rPr lang="en-US" dirty="0">
+                <a:latin typeface="Times New Roman" panose="02020603050405020304" pitchFamily="18" charset="0"/>
+                <a:cs typeface="Times New Roman" panose="02020603050405020304" pitchFamily="18" charset="0"/>
+              </a:rPr>
+              <a:t>: Need For Speed Most Wanted (2005), </a:t>
+            </a:r>
+            <a:r>
+              <a:rPr lang="en-US" dirty="0" err="1">
+                <a:latin typeface="Times New Roman" panose="02020603050405020304" pitchFamily="18" charset="0"/>
+                <a:cs typeface="Times New Roman" panose="02020603050405020304" pitchFamily="18" charset="0"/>
+              </a:rPr>
+              <a:t>jocuri</a:t>
+            </a:r>
+            <a:r>
+              <a:rPr lang="en-US" dirty="0">
+                <a:latin typeface="Times New Roman" panose="02020603050405020304" pitchFamily="18" charset="0"/>
+                <a:cs typeface="Times New Roman" panose="02020603050405020304" pitchFamily="18" charset="0"/>
+              </a:rPr>
+              <a:t> </a:t>
+            </a:r>
+            <a:r>
+              <a:rPr lang="ro-RO" dirty="0">
+                <a:latin typeface="Times New Roman" panose="02020603050405020304" pitchFamily="18" charset="0"/>
+                <a:cs typeface="Times New Roman" panose="02020603050405020304" pitchFamily="18" charset="0"/>
+              </a:rPr>
+              <a:t>î</a:t>
+            </a:r>
+            <a:r>
+              <a:rPr lang="en-US" dirty="0">
+                <a:latin typeface="Times New Roman" panose="02020603050405020304" pitchFamily="18" charset="0"/>
+                <a:cs typeface="Times New Roman" panose="02020603050405020304" pitchFamily="18" charset="0"/>
+              </a:rPr>
+              <a:t>n </a:t>
+            </a:r>
+            <a:r>
+              <a:rPr lang="en-US" dirty="0" err="1">
+                <a:latin typeface="Times New Roman" panose="02020603050405020304" pitchFamily="18" charset="0"/>
+                <a:cs typeface="Times New Roman" panose="02020603050405020304" pitchFamily="18" charset="0"/>
+              </a:rPr>
+              <a:t>stil</a:t>
+            </a:r>
+            <a:r>
+              <a:rPr lang="en-US" dirty="0">
+                <a:latin typeface="Times New Roman" panose="02020603050405020304" pitchFamily="18" charset="0"/>
+                <a:cs typeface="Times New Roman" panose="02020603050405020304" pitchFamily="18" charset="0"/>
+              </a:rPr>
+              <a:t> “arcade” (</a:t>
+            </a:r>
+            <a:r>
+              <a:rPr lang="en-US" dirty="0" err="1">
+                <a:latin typeface="Times New Roman" panose="02020603050405020304" pitchFamily="18" charset="0"/>
+                <a:cs typeface="Times New Roman" panose="02020603050405020304" pitchFamily="18" charset="0"/>
+              </a:rPr>
+              <a:t>unele</a:t>
+            </a:r>
+            <a:r>
+              <a:rPr lang="en-US" dirty="0">
+                <a:latin typeface="Times New Roman" panose="02020603050405020304" pitchFamily="18" charset="0"/>
+                <a:cs typeface="Times New Roman" panose="02020603050405020304" pitchFamily="18" charset="0"/>
+              </a:rPr>
+              <a:t> aspect sunt </a:t>
+            </a:r>
+            <a:r>
+              <a:rPr lang="en-US" dirty="0" err="1">
+                <a:latin typeface="Times New Roman" panose="02020603050405020304" pitchFamily="18" charset="0"/>
+                <a:cs typeface="Times New Roman" panose="02020603050405020304" pitchFamily="18" charset="0"/>
+              </a:rPr>
+              <a:t>exagerate</a:t>
+            </a:r>
+            <a:r>
+              <a:rPr lang="en-US" dirty="0">
+                <a:latin typeface="Times New Roman" panose="02020603050405020304" pitchFamily="18" charset="0"/>
+                <a:cs typeface="Times New Roman" panose="02020603050405020304" pitchFamily="18" charset="0"/>
+              </a:rPr>
+              <a:t>)</a:t>
+            </a:r>
+            <a:r>
+              <a:rPr lang="ro-RO" dirty="0">
+                <a:latin typeface="Times New Roman" panose="02020603050405020304" pitchFamily="18" charset="0"/>
+                <a:cs typeface="Times New Roman" panose="02020603050405020304" pitchFamily="18" charset="0"/>
+              </a:rPr>
+              <a:t>.</a:t>
+            </a:r>
+            <a:endParaRPr lang="en-US" dirty="0">
+              <a:latin typeface="Times New Roman" panose="02020603050405020304" pitchFamily="18" charset="0"/>
+              <a:cs typeface="Times New Roman" panose="02020603050405020304" pitchFamily="18" charset="0"/>
+            </a:endParaRPr>
+          </a:p>
+          <a:p>
+            <a:r>
+              <a:rPr lang="en-US" dirty="0" err="1">
+                <a:latin typeface="Times New Roman" panose="02020603050405020304" pitchFamily="18" charset="0"/>
+                <a:cs typeface="Times New Roman" panose="02020603050405020304" pitchFamily="18" charset="0"/>
+              </a:rPr>
+              <a:t>Obiective</a:t>
+            </a:r>
+            <a:r>
+              <a:rPr lang="en-US" dirty="0">
+                <a:latin typeface="Times New Roman" panose="02020603050405020304" pitchFamily="18" charset="0"/>
+                <a:cs typeface="Times New Roman" panose="02020603050405020304" pitchFamily="18" charset="0"/>
+              </a:rPr>
+              <a:t>: </a:t>
+            </a:r>
+            <a:r>
+              <a:rPr lang="en-US" dirty="0" err="1">
+                <a:latin typeface="Times New Roman" panose="02020603050405020304" pitchFamily="18" charset="0"/>
+                <a:cs typeface="Times New Roman" panose="02020603050405020304" pitchFamily="18" charset="0"/>
+              </a:rPr>
+              <a:t>Crearea</a:t>
+            </a:r>
+            <a:r>
+              <a:rPr lang="en-US" dirty="0">
+                <a:latin typeface="Times New Roman" panose="02020603050405020304" pitchFamily="18" charset="0"/>
+                <a:cs typeface="Times New Roman" panose="02020603050405020304" pitchFamily="18" charset="0"/>
+              </a:rPr>
+              <a:t> ma</a:t>
+            </a:r>
+            <a:r>
+              <a:rPr lang="ro-RO" dirty="0">
+                <a:latin typeface="Times New Roman" panose="02020603050405020304" pitchFamily="18" charset="0"/>
+                <a:cs typeface="Times New Roman" panose="02020603050405020304" pitchFamily="18" charset="0"/>
+              </a:rPr>
+              <a:t>ș</a:t>
+            </a:r>
+            <a:r>
+              <a:rPr lang="en-US" dirty="0" err="1">
+                <a:latin typeface="Times New Roman" panose="02020603050405020304" pitchFamily="18" charset="0"/>
+                <a:cs typeface="Times New Roman" panose="02020603050405020304" pitchFamily="18" charset="0"/>
+              </a:rPr>
+              <a:t>inii</a:t>
+            </a:r>
+            <a:r>
+              <a:rPr lang="en-US" dirty="0">
+                <a:latin typeface="Times New Roman" panose="02020603050405020304" pitchFamily="18" charset="0"/>
+                <a:cs typeface="Times New Roman" panose="02020603050405020304" pitchFamily="18" charset="0"/>
+              </a:rPr>
+              <a:t> de poli</a:t>
+            </a:r>
+            <a:r>
+              <a:rPr lang="ro-RO" dirty="0">
+                <a:latin typeface="Times New Roman" panose="02020603050405020304" pitchFamily="18" charset="0"/>
+                <a:cs typeface="Times New Roman" panose="02020603050405020304" pitchFamily="18" charset="0"/>
+              </a:rPr>
+              <a:t>ț</a:t>
+            </a:r>
+            <a:r>
+              <a:rPr lang="en-US" dirty="0" err="1">
+                <a:latin typeface="Times New Roman" panose="02020603050405020304" pitchFamily="18" charset="0"/>
+                <a:cs typeface="Times New Roman" panose="02020603050405020304" pitchFamily="18" charset="0"/>
+              </a:rPr>
+              <a:t>ie</a:t>
+            </a:r>
+            <a:r>
+              <a:rPr lang="en-US" dirty="0">
+                <a:latin typeface="Times New Roman" panose="02020603050405020304" pitchFamily="18" charset="0"/>
+                <a:cs typeface="Times New Roman" panose="02020603050405020304" pitchFamily="18" charset="0"/>
+              </a:rPr>
+              <a:t>, </a:t>
+            </a:r>
+            <a:r>
+              <a:rPr lang="en-US" dirty="0" err="1">
+                <a:latin typeface="Times New Roman" panose="02020603050405020304" pitchFamily="18" charset="0"/>
+                <a:cs typeface="Times New Roman" panose="02020603050405020304" pitchFamily="18" charset="0"/>
+              </a:rPr>
+              <a:t>ora</a:t>
+            </a:r>
+            <a:r>
+              <a:rPr lang="ro-RO" dirty="0">
+                <a:latin typeface="Times New Roman" panose="02020603050405020304" pitchFamily="18" charset="0"/>
+                <a:cs typeface="Times New Roman" panose="02020603050405020304" pitchFamily="18" charset="0"/>
+              </a:rPr>
+              <a:t>ș</a:t>
+            </a:r>
+            <a:r>
+              <a:rPr lang="en-US" dirty="0" err="1">
+                <a:latin typeface="Times New Roman" panose="02020603050405020304" pitchFamily="18" charset="0"/>
+                <a:cs typeface="Times New Roman" panose="02020603050405020304" pitchFamily="18" charset="0"/>
+              </a:rPr>
+              <a:t>ului</a:t>
+            </a:r>
+            <a:r>
+              <a:rPr lang="en-US" dirty="0">
+                <a:latin typeface="Times New Roman" panose="02020603050405020304" pitchFamily="18" charset="0"/>
+                <a:cs typeface="Times New Roman" panose="02020603050405020304" pitchFamily="18" charset="0"/>
+              </a:rPr>
+              <a:t>, “ma</a:t>
+            </a:r>
+            <a:r>
+              <a:rPr lang="ro-RO" dirty="0">
+                <a:latin typeface="Times New Roman" panose="02020603050405020304" pitchFamily="18" charset="0"/>
+                <a:cs typeface="Times New Roman" panose="02020603050405020304" pitchFamily="18" charset="0"/>
+              </a:rPr>
+              <a:t>ș</a:t>
+            </a:r>
+            <a:r>
+              <a:rPr lang="en-US" dirty="0" err="1">
+                <a:latin typeface="Times New Roman" panose="02020603050405020304" pitchFamily="18" charset="0"/>
+                <a:cs typeface="Times New Roman" panose="02020603050405020304" pitchFamily="18" charset="0"/>
+              </a:rPr>
+              <a:t>inii</a:t>
+            </a:r>
+            <a:r>
+              <a:rPr lang="en-US" dirty="0">
+                <a:latin typeface="Times New Roman" panose="02020603050405020304" pitchFamily="18" charset="0"/>
+                <a:cs typeface="Times New Roman" panose="02020603050405020304" pitchFamily="18" charset="0"/>
+              </a:rPr>
+              <a:t> </a:t>
+            </a:r>
+            <a:r>
+              <a:rPr lang="en-US" dirty="0" err="1">
+                <a:latin typeface="Times New Roman" panose="02020603050405020304" pitchFamily="18" charset="0"/>
+                <a:cs typeface="Times New Roman" panose="02020603050405020304" pitchFamily="18" charset="0"/>
+              </a:rPr>
+              <a:t>criminale</a:t>
+            </a:r>
+            <a:r>
+              <a:rPr lang="en-US" dirty="0">
+                <a:latin typeface="Times New Roman" panose="02020603050405020304" pitchFamily="18" charset="0"/>
+                <a:cs typeface="Times New Roman" panose="02020603050405020304" pitchFamily="18" charset="0"/>
+              </a:rPr>
+              <a:t>”, </a:t>
+            </a:r>
+            <a:r>
+              <a:rPr lang="en-US" dirty="0" err="1">
+                <a:latin typeface="Times New Roman" panose="02020603050405020304" pitchFamily="18" charset="0"/>
+                <a:cs typeface="Times New Roman" panose="02020603050405020304" pitchFamily="18" charset="0"/>
+              </a:rPr>
+              <a:t>modelului</a:t>
+            </a:r>
+            <a:r>
+              <a:rPr lang="en-US" dirty="0">
+                <a:latin typeface="Times New Roman" panose="02020603050405020304" pitchFamily="18" charset="0"/>
+                <a:cs typeface="Times New Roman" panose="02020603050405020304" pitchFamily="18" charset="0"/>
+              </a:rPr>
+              <a:t> de </a:t>
+            </a:r>
+            <a:r>
+              <a:rPr lang="en-US" dirty="0" err="1">
+                <a:latin typeface="Times New Roman" panose="02020603050405020304" pitchFamily="18" charset="0"/>
+                <a:cs typeface="Times New Roman" panose="02020603050405020304" pitchFamily="18" charset="0"/>
+              </a:rPr>
+              <a:t>iluminare</a:t>
+            </a:r>
+            <a:r>
+              <a:rPr lang="en-US" dirty="0">
+                <a:latin typeface="Times New Roman" panose="02020603050405020304" pitchFamily="18" charset="0"/>
+                <a:cs typeface="Times New Roman" panose="02020603050405020304" pitchFamily="18" charset="0"/>
+              </a:rPr>
+              <a:t> / </a:t>
+            </a:r>
+            <a:r>
+              <a:rPr lang="en-US" dirty="0" err="1">
+                <a:latin typeface="Times New Roman" panose="02020603050405020304" pitchFamily="18" charset="0"/>
+                <a:cs typeface="Times New Roman" panose="02020603050405020304" pitchFamily="18" charset="0"/>
+              </a:rPr>
+              <a:t>umbrire</a:t>
+            </a:r>
+            <a:r>
+              <a:rPr lang="en-US" dirty="0">
+                <a:latin typeface="Times New Roman" panose="02020603050405020304" pitchFamily="18" charset="0"/>
+                <a:cs typeface="Times New Roman" panose="02020603050405020304" pitchFamily="18" charset="0"/>
+              </a:rPr>
+              <a:t> </a:t>
+            </a:r>
+            <a:r>
+              <a:rPr lang="en-US" dirty="0" err="1">
+                <a:latin typeface="Times New Roman" panose="02020603050405020304" pitchFamily="18" charset="0"/>
+                <a:cs typeface="Times New Roman" panose="02020603050405020304" pitchFamily="18" charset="0"/>
+              </a:rPr>
+              <a:t>phong</a:t>
+            </a:r>
+            <a:r>
+              <a:rPr lang="en-US" dirty="0">
+                <a:latin typeface="Times New Roman" panose="02020603050405020304" pitchFamily="18" charset="0"/>
+                <a:cs typeface="Times New Roman" panose="02020603050405020304" pitchFamily="18" charset="0"/>
+              </a:rPr>
+              <a:t>, </a:t>
+            </a:r>
+            <a:r>
+              <a:rPr lang="en-US" dirty="0" err="1">
+                <a:latin typeface="Times New Roman" panose="02020603050405020304" pitchFamily="18" charset="0"/>
+                <a:cs typeface="Times New Roman" panose="02020603050405020304" pitchFamily="18" charset="0"/>
+              </a:rPr>
+              <a:t>tehnicilor</a:t>
+            </a:r>
+            <a:r>
+              <a:rPr lang="en-US" dirty="0">
+                <a:latin typeface="Times New Roman" panose="02020603050405020304" pitchFamily="18" charset="0"/>
+                <a:cs typeface="Times New Roman" panose="02020603050405020304" pitchFamily="18" charset="0"/>
+              </a:rPr>
+              <a:t> “shadow map” </a:t>
+            </a:r>
+            <a:r>
+              <a:rPr lang="ro-RO" dirty="0">
+                <a:latin typeface="Times New Roman" panose="02020603050405020304" pitchFamily="18" charset="0"/>
+                <a:cs typeface="Times New Roman" panose="02020603050405020304" pitchFamily="18" charset="0"/>
+              </a:rPr>
+              <a:t>ș</a:t>
+            </a:r>
+            <a:r>
+              <a:rPr lang="en-US" dirty="0" err="1">
+                <a:latin typeface="Times New Roman" panose="02020603050405020304" pitchFamily="18" charset="0"/>
+                <a:cs typeface="Times New Roman" panose="02020603050405020304" pitchFamily="18" charset="0"/>
+              </a:rPr>
+              <a:t>i</a:t>
+            </a:r>
+            <a:r>
+              <a:rPr lang="en-US" dirty="0">
+                <a:latin typeface="Times New Roman" panose="02020603050405020304" pitchFamily="18" charset="0"/>
+                <a:cs typeface="Times New Roman" panose="02020603050405020304" pitchFamily="18" charset="0"/>
+              </a:rPr>
+              <a:t> “shadow cube”</a:t>
+            </a:r>
+            <a:r>
+              <a:rPr lang="ro-RO" dirty="0">
+                <a:latin typeface="Times New Roman" panose="02020603050405020304" pitchFamily="18" charset="0"/>
+                <a:cs typeface="Times New Roman" panose="02020603050405020304" pitchFamily="18" charset="0"/>
+              </a:rPr>
+              <a:t>.</a:t>
+            </a:r>
           </a:p>
         </p:txBody>
       </p:sp>
@@ -4152,6 +4329,13 @@
               </a:rPr>
               <a:t>STB_Image</a:t>
             </a:r>
+            <a:r>
+              <a:rPr lang="ro-RO" dirty="0">
+                <a:latin typeface="Times New Roman" panose="02020603050405020304" pitchFamily="18" charset="0"/>
+                <a:cs typeface="Times New Roman" panose="02020603050405020304" pitchFamily="18" charset="0"/>
+              </a:rPr>
+              <a:t>.</a:t>
+            </a:r>
             <a:endParaRPr lang="en-US" dirty="0">
               <a:latin typeface="Times New Roman" panose="02020603050405020304" pitchFamily="18" charset="0"/>
               <a:cs typeface="Times New Roman" panose="02020603050405020304" pitchFamily="18" charset="0"/>
@@ -4205,7 +4389,14 @@
                 <a:latin typeface="Times New Roman" panose="02020603050405020304" pitchFamily="18" charset="0"/>
                 <a:cs typeface="Times New Roman" panose="02020603050405020304" pitchFamily="18" charset="0"/>
               </a:rPr>
-              <a:t>orientata</a:t>
+              <a:t>orientat</a:t>
+            </a:r>
+            <a:r>
+              <a:rPr lang="ro-RO" dirty="0">
+                <a:latin typeface="Times New Roman" panose="02020603050405020304" pitchFamily="18" charset="0"/>
+                <a:cs typeface="Times New Roman" panose="02020603050405020304" pitchFamily="18" charset="0"/>
+              </a:rPr>
+              <a:t>ă</a:t>
             </a:r>
             <a:r>
               <a:rPr lang="en-US" dirty="0">
@@ -4268,7 +4459,21 @@
                 <a:latin typeface="Times New Roman" panose="02020603050405020304" pitchFamily="18" charset="0"/>
                 <a:cs typeface="Times New Roman" panose="02020603050405020304" pitchFamily="18" charset="0"/>
               </a:rPr>
-              <a:t> in </a:t>
+              <a:t> </a:t>
+            </a:r>
+            <a:r>
+              <a:rPr lang="ro-RO" dirty="0">
+                <a:latin typeface="Times New Roman" panose="02020603050405020304" pitchFamily="18" charset="0"/>
+                <a:cs typeface="Times New Roman" panose="02020603050405020304" pitchFamily="18" charset="0"/>
+              </a:rPr>
+              <a:t>î</a:t>
+            </a:r>
+            <a:r>
+              <a:rPr lang="en-US" dirty="0">
+                <a:latin typeface="Times New Roman" panose="02020603050405020304" pitchFamily="18" charset="0"/>
+                <a:cs typeface="Times New Roman" panose="02020603050405020304" pitchFamily="18" charset="0"/>
+              </a:rPr>
+              <a:t>n </a:t>
             </a:r>
             <a:r>
               <a:rPr lang="en-US" dirty="0" err="1">
@@ -4284,6 +4489,17 @@
               </a:rPr>
               <a:t> C++ (RTTI, RAII), “One Class, Two Files”</a:t>
             </a:r>
+            <a:r>
+              <a:rPr lang="ro-RO" dirty="0">
+                <a:latin typeface="Times New Roman" panose="02020603050405020304" pitchFamily="18" charset="0"/>
+                <a:cs typeface="Times New Roman" panose="02020603050405020304" pitchFamily="18" charset="0"/>
+              </a:rPr>
+              <a:t>.</a:t>
+            </a:r>
+            <a:endParaRPr lang="en-US" dirty="0">
+              <a:latin typeface="Times New Roman" panose="02020603050405020304" pitchFamily="18" charset="0"/>
+              <a:cs typeface="Times New Roman" panose="02020603050405020304" pitchFamily="18" charset="0"/>
+            </a:endParaRPr>
           </a:p>
           <a:p>
             <a:r>
@@ -4298,7 +4514,21 @@
                 <a:latin typeface="Times New Roman" panose="02020603050405020304" pitchFamily="18" charset="0"/>
                 <a:cs typeface="Times New Roman" panose="02020603050405020304" pitchFamily="18" charset="0"/>
               </a:rPr>
-              <a:t> mica: </a:t>
+              <a:t> mic</a:t>
+            </a:r>
+            <a:r>
+              <a:rPr lang="ro-RO" dirty="0">
+                <a:latin typeface="Times New Roman" panose="02020603050405020304" pitchFamily="18" charset="0"/>
+                <a:cs typeface="Times New Roman" panose="02020603050405020304" pitchFamily="18" charset="0"/>
+              </a:rPr>
+              <a:t>ă</a:t>
+            </a:r>
+            <a:r>
+              <a:rPr lang="en-US" dirty="0">
+                <a:latin typeface="Times New Roman" panose="02020603050405020304" pitchFamily="18" charset="0"/>
+                <a:cs typeface="Times New Roman" panose="02020603050405020304" pitchFamily="18" charset="0"/>
+              </a:rPr>
+              <a:t>: </a:t>
             </a:r>
             <a:r>
               <a:rPr lang="en-US" dirty="0" err="1">
@@ -4319,7 +4549,21 @@
                 <a:latin typeface="Times New Roman" panose="02020603050405020304" pitchFamily="18" charset="0"/>
                 <a:cs typeface="Times New Roman" panose="02020603050405020304" pitchFamily="18" charset="0"/>
               </a:rPr>
-              <a:t>consacrati</a:t>
+              <a:t>consacra</a:t>
+            </a:r>
+            <a:r>
+              <a:rPr lang="ro-RO" dirty="0">
+                <a:latin typeface="Times New Roman" panose="02020603050405020304" pitchFamily="18" charset="0"/>
+                <a:cs typeface="Times New Roman" panose="02020603050405020304" pitchFamily="18" charset="0"/>
+              </a:rPr>
+              <a:t>ț</a:t>
+            </a:r>
+            <a:r>
+              <a:rPr lang="en-US" dirty="0" err="1">
+                <a:latin typeface="Times New Roman" panose="02020603050405020304" pitchFamily="18" charset="0"/>
+                <a:cs typeface="Times New Roman" panose="02020603050405020304" pitchFamily="18" charset="0"/>
+              </a:rPr>
+              <a:t>i</a:t>
             </a:r>
             <a:r>
               <a:rPr lang="en-US" dirty="0">
@@ -4385,11 +4629,18 @@
               <a:t> de “shadow map” </a:t>
             </a:r>
             <a:r>
-              <a:rPr lang="en-US" dirty="0" err="1">
-                <a:latin typeface="Times New Roman" panose="02020603050405020304" pitchFamily="18" charset="0"/>
-                <a:cs typeface="Times New Roman" panose="02020603050405020304" pitchFamily="18" charset="0"/>
-              </a:rPr>
-              <a:t>si</a:t>
+              <a:rPr lang="ro-RO" dirty="0">
+                <a:latin typeface="Times New Roman" panose="02020603050405020304" pitchFamily="18" charset="0"/>
+                <a:cs typeface="Times New Roman" panose="02020603050405020304" pitchFamily="18" charset="0"/>
+              </a:rPr>
+              <a:t>ș</a:t>
+            </a:r>
+            <a:r>
+              <a:rPr lang="en-US" dirty="0" err="1">
+                <a:latin typeface="Times New Roman" panose="02020603050405020304" pitchFamily="18" charset="0"/>
+                <a:cs typeface="Times New Roman" panose="02020603050405020304" pitchFamily="18" charset="0"/>
+              </a:rPr>
+              <a:t>i</a:t>
             </a:r>
             <a:r>
               <a:rPr lang="en-US" dirty="0">
@@ -4399,11 +4650,18 @@
               <a:t> “shadow cube”, “Jittered Grid” </a:t>
             </a:r>
             <a:r>
-              <a:rPr lang="en-US" dirty="0" err="1">
-                <a:latin typeface="Times New Roman" panose="02020603050405020304" pitchFamily="18" charset="0"/>
-                <a:cs typeface="Times New Roman" panose="02020603050405020304" pitchFamily="18" charset="0"/>
-              </a:rPr>
-              <a:t>si</a:t>
+              <a:rPr lang="ro-RO" dirty="0">
+                <a:latin typeface="Times New Roman" panose="02020603050405020304" pitchFamily="18" charset="0"/>
+                <a:cs typeface="Times New Roman" panose="02020603050405020304" pitchFamily="18" charset="0"/>
+              </a:rPr>
+              <a:t>ș</a:t>
+            </a:r>
+            <a:r>
+              <a:rPr lang="en-US" dirty="0" err="1">
+                <a:latin typeface="Times New Roman" panose="02020603050405020304" pitchFamily="18" charset="0"/>
+                <a:cs typeface="Times New Roman" panose="02020603050405020304" pitchFamily="18" charset="0"/>
+              </a:rPr>
+              <a:t>i</a:t>
             </a:r>
             <a:r>
               <a:rPr lang="en-US" dirty="0">
@@ -4445,7 +4703,21 @@
                 <a:latin typeface="Times New Roman" panose="02020603050405020304" pitchFamily="18" charset="0"/>
                 <a:cs typeface="Times New Roman" panose="02020603050405020304" pitchFamily="18" charset="0"/>
               </a:rPr>
-              <a:t>orasului</a:t>
+              <a:t>ora</a:t>
+            </a:r>
+            <a:r>
+              <a:rPr lang="ro-RO" dirty="0">
+                <a:latin typeface="Times New Roman" panose="02020603050405020304" pitchFamily="18" charset="0"/>
+                <a:cs typeface="Times New Roman" panose="02020603050405020304" pitchFamily="18" charset="0"/>
+              </a:rPr>
+              <a:t>ș</a:t>
+            </a:r>
+            <a:r>
+              <a:rPr lang="en-US" dirty="0" err="1">
+                <a:latin typeface="Times New Roman" panose="02020603050405020304" pitchFamily="18" charset="0"/>
+                <a:cs typeface="Times New Roman" panose="02020603050405020304" pitchFamily="18" charset="0"/>
+              </a:rPr>
+              <a:t>ului</a:t>
             </a:r>
             <a:r>
               <a:rPr lang="en-US" dirty="0">
@@ -4487,14 +4759,21 @@
                 <a:latin typeface="Times New Roman" panose="02020603050405020304" pitchFamily="18" charset="0"/>
                 <a:cs typeface="Times New Roman" panose="02020603050405020304" pitchFamily="18" charset="0"/>
               </a:rPr>
-              <a:t>transparenta</a:t>
-            </a:r>
-            <a:r>
-              <a:rPr lang="en-US" dirty="0">
-                <a:latin typeface="Times New Roman" panose="02020603050405020304" pitchFamily="18" charset="0"/>
-                <a:cs typeface="Times New Roman" panose="02020603050405020304" pitchFamily="18" charset="0"/>
-              </a:rPr>
-              <a:t> </a:t>
+              <a:t>transparen</a:t>
+            </a:r>
+            <a:r>
+              <a:rPr lang="ro-RO" dirty="0">
+                <a:latin typeface="Times New Roman" panose="02020603050405020304" pitchFamily="18" charset="0"/>
+                <a:cs typeface="Times New Roman" panose="02020603050405020304" pitchFamily="18" charset="0"/>
+              </a:rPr>
+              <a:t>ț</a:t>
+            </a:r>
+            <a:r>
+              <a:rPr lang="en-US" dirty="0">
+                <a:latin typeface="Times New Roman" panose="02020603050405020304" pitchFamily="18" charset="0"/>
+                <a:cs typeface="Times New Roman" panose="02020603050405020304" pitchFamily="18" charset="0"/>
+              </a:rPr>
+              <a:t>a </a:t>
             </a:r>
             <a:r>
               <a:rPr lang="en-US" dirty="0" err="1">
@@ -4524,6 +4803,17 @@
               </a:rPr>
               <a:t> un alt shader</a:t>
             </a:r>
+            <a:r>
+              <a:rPr lang="ro-RO" dirty="0">
+                <a:latin typeface="Times New Roman" panose="02020603050405020304" pitchFamily="18" charset="0"/>
+                <a:cs typeface="Times New Roman" panose="02020603050405020304" pitchFamily="18" charset="0"/>
+              </a:rPr>
+              <a:t>.</a:t>
+            </a:r>
+            <a:endParaRPr lang="en-US" dirty="0">
+              <a:latin typeface="Times New Roman" panose="02020603050405020304" pitchFamily="18" charset="0"/>
+              <a:cs typeface="Times New Roman" panose="02020603050405020304" pitchFamily="18" charset="0"/>
+            </a:endParaRPr>
           </a:p>
         </p:txBody>
       </p:sp>
@@ -4635,6 +4925,97 @@
                 <a:latin typeface="Times New Roman" panose="02020603050405020304" pitchFamily="18" charset="0"/>
                 <a:cs typeface="Times New Roman" panose="02020603050405020304" pitchFamily="18" charset="0"/>
               </a:rPr>
+              <a:t>, ma</a:t>
+            </a:r>
+            <a:r>
+              <a:rPr lang="ro-RO" dirty="0">
+                <a:latin typeface="Times New Roman" panose="02020603050405020304" pitchFamily="18" charset="0"/>
+                <a:cs typeface="Times New Roman" panose="02020603050405020304" pitchFamily="18" charset="0"/>
+              </a:rPr>
+              <a:t>ș</a:t>
+            </a:r>
+            <a:r>
+              <a:rPr lang="en-US" dirty="0" err="1">
+                <a:latin typeface="Times New Roman" panose="02020603050405020304" pitchFamily="18" charset="0"/>
+                <a:cs typeface="Times New Roman" panose="02020603050405020304" pitchFamily="18" charset="0"/>
+              </a:rPr>
+              <a:t>ina</a:t>
+            </a:r>
+            <a:r>
+              <a:rPr lang="en-US" dirty="0">
+                <a:latin typeface="Times New Roman" panose="02020603050405020304" pitchFamily="18" charset="0"/>
+                <a:cs typeface="Times New Roman" panose="02020603050405020304" pitchFamily="18" charset="0"/>
+              </a:rPr>
+              <a:t> de poli</a:t>
+            </a:r>
+            <a:r>
+              <a:rPr lang="ro-RO" dirty="0">
+                <a:latin typeface="Times New Roman" panose="02020603050405020304" pitchFamily="18" charset="0"/>
+                <a:cs typeface="Times New Roman" panose="02020603050405020304" pitchFamily="18" charset="0"/>
+              </a:rPr>
+              <a:t>ț</a:t>
+            </a:r>
+            <a:r>
+              <a:rPr lang="en-US" dirty="0" err="1">
+                <a:latin typeface="Times New Roman" panose="02020603050405020304" pitchFamily="18" charset="0"/>
+                <a:cs typeface="Times New Roman" panose="02020603050405020304" pitchFamily="18" charset="0"/>
+              </a:rPr>
+              <a:t>ie</a:t>
+            </a:r>
+            <a:r>
+              <a:rPr lang="en-US" dirty="0">
+                <a:latin typeface="Times New Roman" panose="02020603050405020304" pitchFamily="18" charset="0"/>
+                <a:cs typeface="Times New Roman" panose="02020603050405020304" pitchFamily="18" charset="0"/>
+              </a:rPr>
+              <a:t> </a:t>
+            </a:r>
+            <a:r>
+              <a:rPr lang="en-US" dirty="0" err="1">
+                <a:latin typeface="Times New Roman" panose="02020603050405020304" pitchFamily="18" charset="0"/>
+                <a:cs typeface="Times New Roman" panose="02020603050405020304" pitchFamily="18" charset="0"/>
+              </a:rPr>
+              <a:t>poate</a:t>
+            </a:r>
+            <a:r>
+              <a:rPr lang="en-US" dirty="0">
+                <a:latin typeface="Times New Roman" panose="02020603050405020304" pitchFamily="18" charset="0"/>
+                <a:cs typeface="Times New Roman" panose="02020603050405020304" pitchFamily="18" charset="0"/>
+              </a:rPr>
+              <a:t> fi </a:t>
+            </a:r>
+            <a:r>
+              <a:rPr lang="en-US" dirty="0" err="1">
+                <a:latin typeface="Times New Roman" panose="02020603050405020304" pitchFamily="18" charset="0"/>
+                <a:cs typeface="Times New Roman" panose="02020603050405020304" pitchFamily="18" charset="0"/>
+              </a:rPr>
+              <a:t>controlat</a:t>
+            </a:r>
+            <a:r>
+              <a:rPr lang="ro-RO" dirty="0">
+                <a:latin typeface="Times New Roman" panose="02020603050405020304" pitchFamily="18" charset="0"/>
+                <a:cs typeface="Times New Roman" panose="02020603050405020304" pitchFamily="18" charset="0"/>
+              </a:rPr>
+              <a:t>ă</a:t>
+            </a:r>
+            <a:r>
+              <a:rPr lang="en-US" dirty="0">
+                <a:latin typeface="Times New Roman" panose="02020603050405020304" pitchFamily="18" charset="0"/>
+                <a:cs typeface="Times New Roman" panose="02020603050405020304" pitchFamily="18" charset="0"/>
+              </a:rPr>
+              <a:t> de </a:t>
+            </a:r>
+            <a:r>
+              <a:rPr lang="en-US" dirty="0" err="1">
+                <a:latin typeface="Times New Roman" panose="02020603050405020304" pitchFamily="18" charset="0"/>
+                <a:cs typeface="Times New Roman" panose="02020603050405020304" pitchFamily="18" charset="0"/>
+              </a:rPr>
+              <a:t>utilizator</a:t>
+            </a:r>
+            <a:r>
+              <a:rPr lang="en-US" dirty="0">
+                <a:latin typeface="Times New Roman" panose="02020603050405020304" pitchFamily="18" charset="0"/>
+                <a:cs typeface="Times New Roman" panose="02020603050405020304" pitchFamily="18" charset="0"/>
+              </a:rPr>
               <a:t>, </a:t>
             </a:r>
             <a:r>
@@ -4642,7 +5023,7 @@
                 <a:latin typeface="Times New Roman" panose="02020603050405020304" pitchFamily="18" charset="0"/>
                 <a:cs typeface="Times New Roman" panose="02020603050405020304" pitchFamily="18" charset="0"/>
               </a:rPr>
-              <a:t>masina</a:t>
+              <a:t>metodele</a:t>
             </a:r>
             <a:r>
               <a:rPr lang="en-US" dirty="0">
@@ -4656,7 +5037,7 @@
                 <a:latin typeface="Times New Roman" panose="02020603050405020304" pitchFamily="18" charset="0"/>
                 <a:cs typeface="Times New Roman" panose="02020603050405020304" pitchFamily="18" charset="0"/>
               </a:rPr>
-              <a:t>politie</a:t>
+              <a:t>iluminare</a:t>
             </a:r>
             <a:r>
               <a:rPr lang="en-US" dirty="0">
@@ -4666,39 +5047,53 @@
               <a:t> </a:t>
             </a:r>
             <a:r>
-              <a:rPr lang="en-US" dirty="0" err="1">
-                <a:latin typeface="Times New Roman" panose="02020603050405020304" pitchFamily="18" charset="0"/>
-                <a:cs typeface="Times New Roman" panose="02020603050405020304" pitchFamily="18" charset="0"/>
-              </a:rPr>
-              <a:t>poate</a:t>
-            </a:r>
-            <a:r>
-              <a:rPr lang="en-US" dirty="0">
-                <a:latin typeface="Times New Roman" panose="02020603050405020304" pitchFamily="18" charset="0"/>
-                <a:cs typeface="Times New Roman" panose="02020603050405020304" pitchFamily="18" charset="0"/>
-              </a:rPr>
-              <a:t> fi </a:t>
-            </a:r>
-            <a:r>
-              <a:rPr lang="en-US" dirty="0" err="1">
-                <a:latin typeface="Times New Roman" panose="02020603050405020304" pitchFamily="18" charset="0"/>
-                <a:cs typeface="Times New Roman" panose="02020603050405020304" pitchFamily="18" charset="0"/>
-              </a:rPr>
-              <a:t>controlata</a:t>
-            </a:r>
-            <a:r>
-              <a:rPr lang="en-US" dirty="0">
-                <a:latin typeface="Times New Roman" panose="02020603050405020304" pitchFamily="18" charset="0"/>
-                <a:cs typeface="Times New Roman" panose="02020603050405020304" pitchFamily="18" charset="0"/>
-              </a:rPr>
-              <a:t> de </a:t>
-            </a:r>
-            <a:r>
-              <a:rPr lang="en-US" dirty="0" err="1">
-                <a:latin typeface="Times New Roman" panose="02020603050405020304" pitchFamily="18" charset="0"/>
-                <a:cs typeface="Times New Roman" panose="02020603050405020304" pitchFamily="18" charset="0"/>
-              </a:rPr>
-              <a:t>utilizator</a:t>
+              <a:rPr lang="ro-RO" dirty="0">
+                <a:latin typeface="Times New Roman" panose="02020603050405020304" pitchFamily="18" charset="0"/>
+                <a:cs typeface="Times New Roman" panose="02020603050405020304" pitchFamily="18" charset="0"/>
+              </a:rPr>
+              <a:t>ș</a:t>
+            </a:r>
+            <a:r>
+              <a:rPr lang="en-US" dirty="0" err="1">
+                <a:latin typeface="Times New Roman" panose="02020603050405020304" pitchFamily="18" charset="0"/>
+                <a:cs typeface="Times New Roman" panose="02020603050405020304" pitchFamily="18" charset="0"/>
+              </a:rPr>
+              <a:t>i</a:t>
+            </a:r>
+            <a:r>
+              <a:rPr lang="en-US" dirty="0">
+                <a:latin typeface="Times New Roman" panose="02020603050405020304" pitchFamily="18" charset="0"/>
+                <a:cs typeface="Times New Roman" panose="02020603050405020304" pitchFamily="18" charset="0"/>
+              </a:rPr>
+              <a:t> </a:t>
+            </a:r>
+            <a:r>
+              <a:rPr lang="en-US" dirty="0" err="1">
+                <a:latin typeface="Times New Roman" panose="02020603050405020304" pitchFamily="18" charset="0"/>
+                <a:cs typeface="Times New Roman" panose="02020603050405020304" pitchFamily="18" charset="0"/>
+              </a:rPr>
+              <a:t>umbrire</a:t>
+            </a:r>
+            <a:r>
+              <a:rPr lang="en-US" dirty="0">
+                <a:latin typeface="Times New Roman" panose="02020603050405020304" pitchFamily="18" charset="0"/>
+                <a:cs typeface="Times New Roman" panose="02020603050405020304" pitchFamily="18" charset="0"/>
+              </a:rPr>
+              <a:t> </a:t>
+            </a:r>
+            <a:r>
+              <a:rPr lang="ro-RO" dirty="0">
+                <a:latin typeface="Times New Roman" panose="02020603050405020304" pitchFamily="18" charset="0"/>
+                <a:cs typeface="Times New Roman" panose="02020603050405020304" pitchFamily="18" charset="0"/>
+              </a:rPr>
+              <a:t>au fost </a:t>
+            </a:r>
+            <a:r>
+              <a:rPr lang="en-US" dirty="0" err="1">
+                <a:latin typeface="Times New Roman" panose="02020603050405020304" pitchFamily="18" charset="0"/>
+                <a:cs typeface="Times New Roman" panose="02020603050405020304" pitchFamily="18" charset="0"/>
+              </a:rPr>
+              <a:t>implementate</a:t>
             </a:r>
             <a:r>
               <a:rPr lang="en-US" dirty="0">
@@ -4712,76 +5107,6 @@
                 <a:latin typeface="Times New Roman" panose="02020603050405020304" pitchFamily="18" charset="0"/>
                 <a:cs typeface="Times New Roman" panose="02020603050405020304" pitchFamily="18" charset="0"/>
               </a:rPr>
-              <a:t>metodele</a:t>
-            </a:r>
-            <a:r>
-              <a:rPr lang="en-US" dirty="0">
-                <a:latin typeface="Times New Roman" panose="02020603050405020304" pitchFamily="18" charset="0"/>
-                <a:cs typeface="Times New Roman" panose="02020603050405020304" pitchFamily="18" charset="0"/>
-              </a:rPr>
-              <a:t> de </a:t>
-            </a:r>
-            <a:r>
-              <a:rPr lang="en-US" dirty="0" err="1">
-                <a:latin typeface="Times New Roman" panose="02020603050405020304" pitchFamily="18" charset="0"/>
-                <a:cs typeface="Times New Roman" panose="02020603050405020304" pitchFamily="18" charset="0"/>
-              </a:rPr>
-              <a:t>iluminare</a:t>
-            </a:r>
-            <a:r>
-              <a:rPr lang="en-US" dirty="0">
-                <a:latin typeface="Times New Roman" panose="02020603050405020304" pitchFamily="18" charset="0"/>
-                <a:cs typeface="Times New Roman" panose="02020603050405020304" pitchFamily="18" charset="0"/>
-              </a:rPr>
-              <a:t> </a:t>
-            </a:r>
-            <a:r>
-              <a:rPr lang="en-US" dirty="0" err="1">
-                <a:latin typeface="Times New Roman" panose="02020603050405020304" pitchFamily="18" charset="0"/>
-                <a:cs typeface="Times New Roman" panose="02020603050405020304" pitchFamily="18" charset="0"/>
-              </a:rPr>
-              <a:t>si</a:t>
-            </a:r>
-            <a:r>
-              <a:rPr lang="en-US" dirty="0">
-                <a:latin typeface="Times New Roman" panose="02020603050405020304" pitchFamily="18" charset="0"/>
-                <a:cs typeface="Times New Roman" panose="02020603050405020304" pitchFamily="18" charset="0"/>
-              </a:rPr>
-              <a:t> </a:t>
-            </a:r>
-            <a:r>
-              <a:rPr lang="en-US" dirty="0" err="1">
-                <a:latin typeface="Times New Roman" panose="02020603050405020304" pitchFamily="18" charset="0"/>
-                <a:cs typeface="Times New Roman" panose="02020603050405020304" pitchFamily="18" charset="0"/>
-              </a:rPr>
-              <a:t>umbrire</a:t>
-            </a:r>
-            <a:r>
-              <a:rPr lang="en-US" dirty="0">
-                <a:latin typeface="Times New Roman" panose="02020603050405020304" pitchFamily="18" charset="0"/>
-                <a:cs typeface="Times New Roman" panose="02020603050405020304" pitchFamily="18" charset="0"/>
-              </a:rPr>
-              <a:t> </a:t>
-            </a:r>
-            <a:r>
-              <a:rPr lang="en-US" dirty="0" err="1">
-                <a:latin typeface="Times New Roman" panose="02020603050405020304" pitchFamily="18" charset="0"/>
-                <a:cs typeface="Times New Roman" panose="02020603050405020304" pitchFamily="18" charset="0"/>
-              </a:rPr>
-              <a:t>implementate</a:t>
-            </a:r>
-            <a:r>
-              <a:rPr lang="en-US" dirty="0">
-                <a:latin typeface="Times New Roman" panose="02020603050405020304" pitchFamily="18" charset="0"/>
-                <a:cs typeface="Times New Roman" panose="02020603050405020304" pitchFamily="18" charset="0"/>
-              </a:rPr>
-              <a:t>, </a:t>
-            </a:r>
-            <a:r>
-              <a:rPr lang="en-US" dirty="0" err="1">
-                <a:latin typeface="Times New Roman" panose="02020603050405020304" pitchFamily="18" charset="0"/>
-                <a:cs typeface="Times New Roman" panose="02020603050405020304" pitchFamily="18" charset="0"/>
-              </a:rPr>
               <a:t>implementat</a:t>
             </a:r>
             <a:r>
@@ -4789,28 +5114,35 @@
                 <a:latin typeface="Times New Roman" panose="02020603050405020304" pitchFamily="18" charset="0"/>
                 <a:cs typeface="Times New Roman" panose="02020603050405020304" pitchFamily="18" charset="0"/>
               </a:rPr>
-              <a:t> “</a:t>
-            </a:r>
-            <a:r>
-              <a:rPr lang="en-US" dirty="0" err="1">
-                <a:latin typeface="Times New Roman" panose="02020603050405020304" pitchFamily="18" charset="0"/>
-                <a:cs typeface="Times New Roman" panose="02020603050405020304" pitchFamily="18" charset="0"/>
-              </a:rPr>
-              <a:t>masina</a:t>
-            </a:r>
-            <a:r>
-              <a:rPr lang="en-US" dirty="0">
-                <a:latin typeface="Times New Roman" panose="02020603050405020304" pitchFamily="18" charset="0"/>
-                <a:cs typeface="Times New Roman" panose="02020603050405020304" pitchFamily="18" charset="0"/>
-              </a:rPr>
-              <a:t> </a:t>
-            </a:r>
-            <a:r>
-              <a:rPr lang="en-US" dirty="0" err="1">
-                <a:latin typeface="Times New Roman" panose="02020603050405020304" pitchFamily="18" charset="0"/>
-                <a:cs typeface="Times New Roman" panose="02020603050405020304" pitchFamily="18" charset="0"/>
-              </a:rPr>
-              <a:t>criminala</a:t>
+              <a:t> “ma</a:t>
+            </a:r>
+            <a:r>
+              <a:rPr lang="ro-RO" dirty="0">
+                <a:latin typeface="Times New Roman" panose="02020603050405020304" pitchFamily="18" charset="0"/>
+                <a:cs typeface="Times New Roman" panose="02020603050405020304" pitchFamily="18" charset="0"/>
+              </a:rPr>
+              <a:t>ș</a:t>
+            </a:r>
+            <a:r>
+              <a:rPr lang="en-US" dirty="0" err="1">
+                <a:latin typeface="Times New Roman" panose="02020603050405020304" pitchFamily="18" charset="0"/>
+                <a:cs typeface="Times New Roman" panose="02020603050405020304" pitchFamily="18" charset="0"/>
+              </a:rPr>
+              <a:t>ina</a:t>
+            </a:r>
+            <a:r>
+              <a:rPr lang="en-US" dirty="0">
+                <a:latin typeface="Times New Roman" panose="02020603050405020304" pitchFamily="18" charset="0"/>
+                <a:cs typeface="Times New Roman" panose="02020603050405020304" pitchFamily="18" charset="0"/>
+              </a:rPr>
+              <a:t> criminal</a:t>
+            </a:r>
+            <a:r>
+              <a:rPr lang="ro-RO" dirty="0">
+                <a:latin typeface="Times New Roman" panose="02020603050405020304" pitchFamily="18" charset="0"/>
+                <a:cs typeface="Times New Roman" panose="02020603050405020304" pitchFamily="18" charset="0"/>
+              </a:rPr>
+              <a:t>ă</a:t>
             </a:r>
             <a:r>
               <a:rPr lang="en-US" dirty="0">
@@ -4819,6 +5151,17 @@
               </a:rPr>
               <a:t>”, X-RAY</a:t>
             </a:r>
+            <a:r>
+              <a:rPr lang="ro-RO" dirty="0">
+                <a:latin typeface="Times New Roman" panose="02020603050405020304" pitchFamily="18" charset="0"/>
+                <a:cs typeface="Times New Roman" panose="02020603050405020304" pitchFamily="18" charset="0"/>
+              </a:rPr>
+              <a:t>.</a:t>
+            </a:r>
+            <a:endParaRPr lang="en-US" dirty="0">
+              <a:latin typeface="Times New Roman" panose="02020603050405020304" pitchFamily="18" charset="0"/>
+              <a:cs typeface="Times New Roman" panose="02020603050405020304" pitchFamily="18" charset="0"/>
+            </a:endParaRPr>
           </a:p>
           <a:p>
             <a:pPr marL="0" indent="0">
@@ -5195,20 +5538,40 @@
               <a:rPr lang="en-US" dirty="0" err="1"/>
               <a:t>propuse</a:t>
             </a:r>
+            <a:r>
+              <a:rPr lang="ro-RO" dirty="0"/>
+              <a:t>.</a:t>
+            </a:r>
             <a:endParaRPr lang="en-US" dirty="0"/>
           </a:p>
           <a:p>
             <a:r>
               <a:rPr lang="en-US" dirty="0" err="1"/>
-              <a:t>Dificultati</a:t>
+              <a:t>Dificult</a:t>
+            </a:r>
+            <a:r>
+              <a:rPr lang="ro-RO" dirty="0"/>
+              <a:t>ăț</a:t>
             </a:r>
             <a:r>
               <a:rPr lang="en-US" dirty="0"/>
-              <a:t>: “shadow mapping” cu peter panning minim </a:t>
+              <a:t>i: “shadow mapping” cu “peter panning”</a:t>
+            </a:r>
+            <a:r>
+              <a:rPr lang="ro-RO" dirty="0"/>
+              <a:t> </a:t>
+            </a:r>
+            <a:r>
+              <a:rPr lang="en-US" dirty="0"/>
+              <a:t>minim </a:t>
+            </a:r>
+            <a:r>
+              <a:rPr lang="ro-RO" dirty="0"/>
+              <a:t>ș</a:t>
             </a:r>
             <a:r>
               <a:rPr lang="en-US" dirty="0" err="1"/>
-              <a:t>si</a:t>
+              <a:t>i</a:t>
             </a:r>
             <a:r>
               <a:rPr lang="en-US" dirty="0"/>
@@ -5219,8 +5582,20 @@
               <a:t>evitare</a:t>
             </a:r>
             <a:r>
+              <a:rPr lang="ro-RO" dirty="0"/>
+              <a:t>a</a:t>
+            </a:r>
+            <a:r>
               <a:rPr lang="en-US" dirty="0"/>
-              <a:t> effect de “</a:t>
+              <a:t> effect</a:t>
+            </a:r>
+            <a:r>
+              <a:rPr lang="ro-RO" dirty="0"/>
+              <a:t>-ului</a:t>
+            </a:r>
+            <a:r>
+              <a:rPr lang="en-US" dirty="0"/>
+              <a:t> de “</a:t>
             </a:r>
             <a:r>
               <a:rPr lang="en-US" dirty="0" err="1"/>
@@ -5228,11 +5603,15 @@
             </a:r>
             <a:r>
               <a:rPr lang="en-US" dirty="0"/>
-              <a:t>” (“shadow acne”). </a:t>
+              <a:t>” (“shadow acne”). G</a:t>
+            </a:r>
+            <a:r>
+              <a:rPr lang="ro-RO" dirty="0"/>
+              <a:t>ă</a:t>
             </a:r>
             <a:r>
               <a:rPr lang="en-US" dirty="0" err="1"/>
-              <a:t>Gasirea</a:t>
+              <a:t>sirea</a:t>
             </a:r>
             <a:r>
               <a:rPr lang="en-US" dirty="0"/>
@@ -5248,7 +5627,23 @@
             </a:r>
             <a:r>
               <a:rPr lang="en-US" dirty="0" err="1"/>
-              <a:t>balante</a:t>
+              <a:t>balan</a:t>
+            </a:r>
+            <a:r>
+              <a:rPr lang="ro-RO" dirty="0"/>
+              <a:t>ț</a:t>
+            </a:r>
+            <a:r>
+              <a:rPr lang="en-US" dirty="0"/>
+              <a:t>e </a:t>
+            </a:r>
+            <a:r>
+              <a:rPr lang="ro-RO" dirty="0"/>
+              <a:t>î</a:t>
+            </a:r>
+            <a:r>
+              <a:rPr lang="en-US" dirty="0" err="1"/>
+              <a:t>ntre</a:t>
             </a:r>
             <a:r>
               <a:rPr lang="en-US" dirty="0"/>
@@ -5256,15 +5651,23 @@
             </a:r>
             <a:r>
               <a:rPr lang="en-US" dirty="0" err="1"/>
-              <a:t>intre</a:t>
+              <a:t>performan</a:t>
+            </a:r>
+            <a:r>
+              <a:rPr lang="ro-RO" dirty="0"/>
+              <a:t>ță</a:t>
             </a:r>
             <a:r>
               <a:rPr lang="en-US" dirty="0"/>
               <a:t> </a:t>
             </a:r>
             <a:r>
+              <a:rPr lang="ro-RO" dirty="0"/>
+              <a:t>ș</a:t>
+            </a:r>
+            <a:r>
               <a:rPr lang="en-US" dirty="0" err="1"/>
-              <a:t>performanta</a:t>
+              <a:t>i</a:t>
             </a:r>
             <a:r>
               <a:rPr lang="en-US" dirty="0"/>
@@ -5272,7 +5675,7 @@
             </a:r>
             <a:r>
               <a:rPr lang="en-US" dirty="0" err="1"/>
-              <a:t>si</a:t>
+              <a:t>fidelitate</a:t>
             </a:r>
             <a:r>
               <a:rPr lang="en-US" dirty="0"/>
@@ -5280,7 +5683,21 @@
             </a:r>
             <a:r>
               <a:rPr lang="en-US" dirty="0" err="1"/>
-              <a:t>fidelitate</a:t>
+              <a:t>grafic</a:t>
+            </a:r>
+            <a:r>
+              <a:rPr lang="ro-RO" dirty="0"/>
+              <a:t>ă</a:t>
+            </a:r>
+            <a:r>
+              <a:rPr lang="en-US" dirty="0"/>
+              <a:t>.</a:t>
+            </a:r>
+          </a:p>
+          <a:p>
+            <a:r>
+              <a:rPr lang="en-US" dirty="0" err="1"/>
+              <a:t>Puncte</a:t>
             </a:r>
             <a:r>
               <a:rPr lang="en-US" dirty="0"/>
@@ -5288,7 +5705,111 @@
             </a:r>
             <a:r>
               <a:rPr lang="en-US" dirty="0" err="1"/>
-              <a:t>grafica</a:t>
+              <a:t>viitoare</a:t>
+            </a:r>
+            <a:r>
+              <a:rPr lang="en-US" dirty="0"/>
+              <a:t> de </a:t>
+            </a:r>
+            <a:r>
+              <a:rPr lang="en-US" dirty="0" err="1"/>
+              <a:t>dezvoltare</a:t>
+            </a:r>
+            <a:r>
+              <a:rPr lang="en-US" dirty="0"/>
+              <a:t>: </a:t>
+            </a:r>
+            <a:r>
+              <a:rPr lang="en-US" dirty="0" err="1"/>
+              <a:t>optimizare</a:t>
+            </a:r>
+            <a:r>
+              <a:rPr lang="en-US" dirty="0"/>
+              <a:t>, </a:t>
+            </a:r>
+            <a:r>
+              <a:rPr lang="en-US" dirty="0" err="1"/>
+              <a:t>spargerea</a:t>
+            </a:r>
+            <a:r>
+              <a:rPr lang="en-US" dirty="0"/>
+              <a:t> </a:t>
+            </a:r>
+            <a:r>
+              <a:rPr lang="en-US" dirty="0" err="1"/>
+              <a:t>claselor</a:t>
+            </a:r>
+            <a:r>
+              <a:rPr lang="en-US" dirty="0"/>
+              <a:t> ‘</a:t>
+            </a:r>
+            <a:r>
+              <a:rPr lang="en-US" dirty="0" err="1"/>
+              <a:t>mari</a:t>
+            </a:r>
+            <a:r>
+              <a:rPr lang="en-US" dirty="0"/>
+              <a:t>’ </a:t>
+            </a:r>
+            <a:r>
+              <a:rPr lang="ro-RO" dirty="0"/>
+              <a:t>î</a:t>
+            </a:r>
+            <a:r>
+              <a:rPr lang="en-US" dirty="0"/>
+              <a:t>n </a:t>
+            </a:r>
+            <a:r>
+              <a:rPr lang="en-US" dirty="0" err="1"/>
+              <a:t>subclase</a:t>
+            </a:r>
+            <a:r>
+              <a:rPr lang="en-US" dirty="0"/>
+              <a:t> </a:t>
+            </a:r>
+            <a:r>
+              <a:rPr lang="en-US" dirty="0" err="1"/>
+              <a:t>specializa</a:t>
+            </a:r>
+            <a:r>
+              <a:rPr lang="ro-RO" dirty="0"/>
+              <a:t>t</a:t>
+            </a:r>
+            <a:r>
+              <a:rPr lang="en-US" dirty="0"/>
+              <a:t>e, ad</a:t>
+            </a:r>
+            <a:r>
+              <a:rPr lang="ro-RO" dirty="0"/>
+              <a:t>ă</a:t>
+            </a:r>
+            <a:r>
+              <a:rPr lang="en-US" dirty="0" err="1"/>
+              <a:t>ugarea</a:t>
+            </a:r>
+            <a:r>
+              <a:rPr lang="en-US" dirty="0"/>
+              <a:t> </a:t>
+            </a:r>
+            <a:r>
+              <a:rPr lang="en-US" dirty="0" err="1"/>
+              <a:t>unui</a:t>
+            </a:r>
+            <a:r>
+              <a:rPr lang="en-US" dirty="0"/>
+              <a:t> ‘physics engine’ </a:t>
+            </a:r>
+            <a:r>
+              <a:rPr lang="en-US" dirty="0" err="1"/>
+              <a:t>sau</a:t>
+            </a:r>
+            <a:r>
+              <a:rPr lang="en-US" dirty="0"/>
+              <a:t> a </a:t>
+            </a:r>
+            <a:r>
+              <a:rPr lang="en-US" dirty="0" err="1"/>
+              <a:t>coliziunilor</a:t>
             </a:r>
             <a:r>
               <a:rPr lang="en-US" dirty="0"/>
@@ -5298,7 +5819,27 @@
           <a:p>
             <a:r>
               <a:rPr lang="en-US" dirty="0" err="1"/>
-              <a:t>Puncte</a:t>
+              <a:t>Contribu</a:t>
+            </a:r>
+            <a:r>
+              <a:rPr lang="ro-RO" dirty="0"/>
+              <a:t>ț</a:t>
+            </a:r>
+            <a:r>
+              <a:rPr lang="en-US" dirty="0"/>
+              <a:t>ii </a:t>
+            </a:r>
+            <a:r>
+              <a:rPr lang="en-US" dirty="0" err="1"/>
+              <a:t>personale</a:t>
+            </a:r>
+            <a:r>
+              <a:rPr lang="en-US" dirty="0"/>
+              <a:t>: </a:t>
+            </a:r>
+            <a:r>
+              <a:rPr lang="en-US" dirty="0" err="1"/>
+              <a:t>proiectare</a:t>
             </a:r>
             <a:r>
               <a:rPr lang="en-US" dirty="0"/>
@@ -5306,55 +5847,23 @@
             </a:r>
             <a:r>
               <a:rPr lang="en-US" dirty="0" err="1"/>
-              <a:t>viitoare</a:t>
-            </a:r>
-            <a:r>
-              <a:rPr lang="en-US" dirty="0"/>
-              <a:t> de </a:t>
-            </a:r>
-            <a:r>
-              <a:rPr lang="en-US" dirty="0" err="1"/>
-              <a:t>dezvoltare</a:t>
-            </a:r>
-            <a:r>
-              <a:rPr lang="en-US" dirty="0"/>
-              <a:t>: </a:t>
-            </a:r>
-            <a:r>
-              <a:rPr lang="en-US" dirty="0" err="1"/>
-              <a:t>optimizare</a:t>
-            </a:r>
-            <a:r>
-              <a:rPr lang="en-US" dirty="0"/>
-              <a:t>, </a:t>
-            </a:r>
-            <a:r>
-              <a:rPr lang="en-US" dirty="0" err="1"/>
-              <a:t>spargerea</a:t>
+              <a:t>balansat</a:t>
+            </a:r>
+            <a:r>
+              <a:rPr lang="ro-RO" dirty="0"/>
+              <a:t>ă</a:t>
             </a:r>
             <a:r>
               <a:rPr lang="en-US" dirty="0"/>
               <a:t> </a:t>
             </a:r>
             <a:r>
+              <a:rPr lang="ro-RO" dirty="0"/>
+              <a:t>î</a:t>
+            </a:r>
+            <a:r>
               <a:rPr lang="en-US" dirty="0" err="1"/>
-              <a:t>claselor</a:t>
-            </a:r>
-            <a:r>
-              <a:rPr lang="en-US" dirty="0"/>
-              <a:t> ‘</a:t>
-            </a:r>
-            <a:r>
-              <a:rPr lang="en-US" dirty="0" err="1"/>
-              <a:t>mari</a:t>
-            </a:r>
-            <a:r>
-              <a:rPr lang="en-US" dirty="0"/>
-              <a:t>’ in </a:t>
-            </a:r>
-            <a:r>
-              <a:rPr lang="en-US" dirty="0" err="1"/>
-              <a:t>subclase</a:t>
+              <a:t>ntre</a:t>
             </a:r>
             <a:r>
               <a:rPr lang="en-US" dirty="0"/>
@@ -5362,49 +5871,23 @@
             </a:r>
             <a:r>
               <a:rPr lang="en-US" dirty="0" err="1"/>
-              <a:t>specializare</a:t>
-            </a:r>
-            <a:r>
-              <a:rPr lang="en-US" dirty="0"/>
-              <a:t>, </a:t>
-            </a:r>
-            <a:r>
-              <a:rPr lang="en-US" dirty="0" err="1"/>
-              <a:t>adaugarea</a:t>
+              <a:t>vitez</a:t>
+            </a:r>
+            <a:r>
+              <a:rPr lang="ro-RO" dirty="0"/>
+              <a:t>ă</a:t>
             </a:r>
             <a:r>
               <a:rPr lang="en-US" dirty="0"/>
               <a:t> </a:t>
             </a:r>
             <a:r>
+              <a:rPr lang="ro-RO" dirty="0"/>
+              <a:t>ș</a:t>
+            </a:r>
+            <a:r>
               <a:rPr lang="en-US" dirty="0" err="1"/>
-              <a:t>unui</a:t>
-            </a:r>
-            <a:r>
-              <a:rPr lang="en-US" dirty="0"/>
-              <a:t> ‘physics engine’ </a:t>
-            </a:r>
-            <a:r>
-              <a:rPr lang="en-US" dirty="0" err="1"/>
-              <a:t>sau</a:t>
-            </a:r>
-            <a:r>
-              <a:rPr lang="en-US" dirty="0"/>
-              <a:t> a </a:t>
-            </a:r>
-            <a:r>
-              <a:rPr lang="en-US" dirty="0" err="1"/>
-              <a:t>coliziunilor</a:t>
-            </a:r>
-            <a:r>
-              <a:rPr lang="en-US" dirty="0"/>
-              <a:t>.</a:t>
-            </a:r>
-          </a:p>
-          <a:p>
-            <a:r>
-              <a:rPr lang="en-US" dirty="0" err="1"/>
-              <a:t>Contributii</a:t>
+              <a:t>i</a:t>
             </a:r>
             <a:r>
               <a:rPr lang="en-US" dirty="0"/>
@@ -5412,71 +5895,11 @@
             </a:r>
             <a:r>
               <a:rPr lang="en-US" dirty="0" err="1"/>
-              <a:t>personale</a:t>
-            </a:r>
-            <a:r>
-              <a:rPr lang="en-US" dirty="0"/>
-              <a:t>: </a:t>
-            </a:r>
-            <a:r>
-              <a:rPr lang="en-US" dirty="0" err="1"/>
-              <a:t>proiectare</a:t>
-            </a:r>
-            <a:r>
-              <a:rPr lang="en-US" dirty="0"/>
-              <a:t> </a:t>
-            </a:r>
-            <a:r>
-              <a:rPr lang="en-US" dirty="0" err="1"/>
-              <a:t>balansata</a:t>
-            </a:r>
-            <a:r>
-              <a:rPr lang="en-US" dirty="0"/>
-              <a:t> </a:t>
-            </a:r>
-            <a:r>
-              <a:rPr lang="en-US" dirty="0" err="1"/>
-              <a:t>intre</a:t>
-            </a:r>
-            <a:r>
-              <a:rPr lang="en-US" dirty="0"/>
-              <a:t> </a:t>
-            </a:r>
-            <a:r>
-              <a:rPr lang="en-US" dirty="0" err="1"/>
-              <a:t>vitezi</a:t>
-            </a:r>
-            <a:r>
-              <a:rPr lang="en-US" dirty="0"/>
-              <a:t> </a:t>
-            </a:r>
-            <a:r>
-              <a:rPr lang="en-US" dirty="0" err="1"/>
-              <a:t>si</a:t>
-            </a:r>
-            <a:r>
-              <a:rPr lang="en-US" dirty="0"/>
-              <a:t> </a:t>
-            </a:r>
-            <a:r>
-              <a:rPr lang="en-US" dirty="0" err="1"/>
-              <a:t>corectitudine</a:t>
-            </a:r>
-            <a:r>
-              <a:rPr lang="en-US" dirty="0"/>
-              <a:t>, </a:t>
-            </a:r>
-            <a:r>
-              <a:rPr lang="en-US" dirty="0" err="1"/>
-              <a:t>ideea</a:t>
-            </a:r>
-            <a:r>
-              <a:rPr lang="en-US" dirty="0"/>
-              <a:t> de </a:t>
-            </a:r>
-            <a:r>
-              <a:rPr lang="en-US" dirty="0" err="1"/>
-              <a:t>proiect</a:t>
+              <a:t>corectitudin</a:t>
+            </a:r>
+            <a:r>
+              <a:rPr lang="ro-RO" dirty="0"/>
+              <a:t>e, expandarea ideii originale propuse</a:t>
             </a:r>
             <a:r>
               <a:rPr lang="en-US" dirty="0"/>

</xml_diff>